<commit_message>
fix: adding speech-to-text API key
</commit_message>
<xml_diff>
--- a/NexFlow-Presentation.pptx
+++ b/NexFlow-Presentation.pptx
@@ -12763,8 +12763,8 @@
         </p:nvSpPr>
         <p:spPr>
           <a:xfrm>
-            <a:off x="800100" y="2468880"/>
-            <a:ext cx="2331720" cy="1078992"/>
+            <a:off x="800100" y="2395728"/>
+            <a:ext cx="2331720" cy="1207008"/>
           </a:xfrm>
           <a:prstGeom prst="rect">
             <a:avLst/>
@@ -12795,7 +12795,7 @@
         </p:nvSpPr>
         <p:spPr>
           <a:xfrm>
-            <a:off x="891540" y="2542032"/>
+            <a:off x="891540" y="2468880"/>
             <a:ext cx="2148840" cy="530352"/>
           </a:xfrm>
           <a:prstGeom prst="rect">
@@ -12834,7 +12834,7 @@
         </p:nvSpPr>
         <p:spPr>
           <a:xfrm>
-            <a:off x="891540" y="3054096"/>
+            <a:off x="891540" y="2980944"/>
             <a:ext cx="2148840" cy="237744"/>
           </a:xfrm>
           <a:prstGeom prst="rect">
@@ -12873,7 +12873,7 @@
         </p:nvSpPr>
         <p:spPr>
           <a:xfrm>
-            <a:off x="891540" y="3273552"/>
+            <a:off x="891540" y="3200400"/>
             <a:ext cx="2148840" cy="201168"/>
           </a:xfrm>
           <a:prstGeom prst="rect">
@@ -12912,8 +12912,8 @@
         </p:nvSpPr>
         <p:spPr>
           <a:xfrm>
-            <a:off x="3406140" y="2468880"/>
-            <a:ext cx="2331720" cy="1078992"/>
+            <a:off x="3406140" y="2395728"/>
+            <a:ext cx="2331720" cy="1207008"/>
           </a:xfrm>
           <a:prstGeom prst="rect">
             <a:avLst/>
@@ -12944,7 +12944,7 @@
         </p:nvSpPr>
         <p:spPr>
           <a:xfrm>
-            <a:off x="3497580" y="2542032"/>
+            <a:off x="3497580" y="2468880"/>
             <a:ext cx="2148840" cy="530352"/>
           </a:xfrm>
           <a:prstGeom prst="rect">
@@ -12983,7 +12983,7 @@
         </p:nvSpPr>
         <p:spPr>
           <a:xfrm>
-            <a:off x="3497580" y="3054096"/>
+            <a:off x="3497580" y="2980944"/>
             <a:ext cx="2148840" cy="237744"/>
           </a:xfrm>
           <a:prstGeom prst="rect">
@@ -13022,7 +13022,7 @@
         </p:nvSpPr>
         <p:spPr>
           <a:xfrm>
-            <a:off x="3497580" y="3273552"/>
+            <a:off x="3497580" y="3200400"/>
             <a:ext cx="2148840" cy="201168"/>
           </a:xfrm>
           <a:prstGeom prst="rect">
@@ -13061,8 +13061,8 @@
         </p:nvSpPr>
         <p:spPr>
           <a:xfrm>
-            <a:off x="6012180" y="2468880"/>
-            <a:ext cx="2331720" cy="1078992"/>
+            <a:off x="6012180" y="2395728"/>
+            <a:ext cx="2331720" cy="1207008"/>
           </a:xfrm>
           <a:prstGeom prst="rect">
             <a:avLst/>
@@ -13093,7 +13093,7 @@
         </p:nvSpPr>
         <p:spPr>
           <a:xfrm>
-            <a:off x="6103620" y="2542032"/>
+            <a:off x="6103620" y="2468880"/>
             <a:ext cx="2148840" cy="530352"/>
           </a:xfrm>
           <a:prstGeom prst="rect">
@@ -13132,7 +13132,7 @@
         </p:nvSpPr>
         <p:spPr>
           <a:xfrm>
-            <a:off x="6103620" y="3054096"/>
+            <a:off x="6103620" y="2980944"/>
             <a:ext cx="2148840" cy="237744"/>
           </a:xfrm>
           <a:prstGeom prst="rect">
@@ -13171,7 +13171,7 @@
         </p:nvSpPr>
         <p:spPr>
           <a:xfrm>
-            <a:off x="6103620" y="3273552"/>
+            <a:off x="6103620" y="3200400"/>
             <a:ext cx="2148840" cy="201168"/>
           </a:xfrm>
           <a:prstGeom prst="rect">

</xml_diff>